<commit_message>
Home Credit: present it as competition participation (AUC 0.774), not a ranking
Leaderboard image without the rank label, score-progression tag and deck
updated accordingly.

Co-Authored-By: Claude Opus 5.5 <noreply@anthropic.com>
</commit_message>
<xml_diff>
--- a/proyectos/home-credit-default-risk-gci-utokyo/slides/home_credit_deck.pptx
+++ b/proyectos/home-credit-default-risk-gci-utokyo/slides/home_credit_deck.pptx
@@ -3292,7 +3292,7 @@
                 </a:solidFill>
                 <a:latin typeface="Inter BUGS"/>
               </a:rPr>
-              <a:t>Top 16 en la competencia de ML de GCI World 2026 · The University of Tokyo</a:t>
+              <a:t>Competencia de ML de GCI World 2026 · Matsuo-Iwasawa Lab, The University of Tokyo</a:t>
             </a:r>
           </a:p>
         </p:txBody>
@@ -5342,7 +5342,7 @@
                 </a:solidFill>
                 <a:latin typeface="Inter BUGS"/>
               </a:rPr>
-              <a:t>Top 16 del leaderboard</a:t>
+              <a:t>leaderboard de la competencia</a:t>
             </a:r>
           </a:p>
         </p:txBody>

</xml_diff>

<commit_message>
Home Credit deck: EDA charts instead of the code slide
Co-Authored-By: Claude Opus 5.5 <noreply@anthropic.com>
</commit_message>
<xml_diff>
--- a/proyectos/home-credit-default-risk-gci-utokyo/slides/home_credit_deck.pptx
+++ b/proyectos/home-credit-default-risk-gci-utokyo/slides/home_credit_deck.pptx
@@ -14,6 +14,7 @@
     <p:sldId id="262" r:id="rId13"/>
     <p:sldId id="263" r:id="rId14"/>
     <p:sldId id="264" r:id="rId15"/>
+    <p:sldId id="265" r:id="rId16"/>
   </p:sldIdLst>
   <p:sldSz cx="12191695" cy="6858000" type="screen4x3"/>
   <p:notesSz cx="6858000" cy="9144000"/>
@@ -3384,6 +3385,225 @@
 </p:sld>
 </file>
 
+<file path=ppt/slides/slide10.xml><?xml version="1.0" encoding="utf-8"?>
+<p:sld xmlns:a="http://schemas.openxmlformats.org/drawingml/2006/main" xmlns:p="http://schemas.openxmlformats.org/presentationml/2006/main" xmlns:r="http://schemas.openxmlformats.org/officeDocument/2006/relationships">
+  <p:cSld>
+    <p:bg>
+      <p:bgPr>
+        <a:solidFill>
+          <a:srgbClr val="0A0A0B"/>
+        </a:solidFill>
+        <a:effectLst/>
+      </p:bgPr>
+    </p:bg>
+    <p:spTree>
+      <p:nvGrpSpPr>
+        <p:cNvPr id="1" name=""/>
+        <p:cNvGrpSpPr/>
+        <p:nvPr/>
+      </p:nvGrpSpPr>
+      <p:grpSpPr/>
+      <p:sp>
+        <p:nvSpPr>
+          <p:cNvPr id="2" name="Parallelogram 1"/>
+          <p:cNvSpPr/>
+          <p:nvPr/>
+        </p:nvSpPr>
+        <p:spPr>
+          <a:xfrm>
+            <a:off x="7223760" y="0"/>
+            <a:ext cx="6035040" cy="6858000"/>
+          </a:xfrm>
+          <a:prstGeom prst="parallelogram">
+            <a:avLst/>
+          </a:prstGeom>
+          <a:solidFill>
+            <a:srgbClr val="FF2E3A"/>
+          </a:solidFill>
+          <a:ln>
+            <a:noFill/>
+          </a:ln>
+          <a:effectLst/>
+        </p:spPr>
+        <p:style>
+          <a:lnRef idx="1">
+            <a:schemeClr val="accent1"/>
+          </a:lnRef>
+          <a:fillRef idx="3">
+            <a:schemeClr val="accent1"/>
+          </a:fillRef>
+          <a:effectRef idx="2">
+            <a:schemeClr val="accent1"/>
+          </a:effectRef>
+          <a:fontRef idx="minor">
+            <a:schemeClr val="lt1"/>
+          </a:fontRef>
+        </p:style>
+        <p:txBody>
+          <a:bodyPr rtlCol="0" anchor="ctr"/>
+          <a:lstStyle/>
+          <a:p>
+            <a:pPr algn="ctr"/>
+          </a:p>
+        </p:txBody>
+      </p:sp>
+      <p:sp>
+        <p:nvSpPr>
+          <p:cNvPr id="3" name="TextBox 2"/>
+          <p:cNvSpPr txBox="1"/>
+          <p:nvPr/>
+        </p:nvSpPr>
+        <p:spPr>
+          <a:xfrm>
+            <a:off x="548640" y="1828800"/>
+            <a:ext cx="6400800" cy="1828800"/>
+          </a:xfrm>
+          <a:prstGeom prst="rect">
+            <a:avLst/>
+          </a:prstGeom>
+          <a:noFill/>
+        </p:spPr>
+        <p:txBody>
+          <a:bodyPr wrap="square" lIns="0" rIns="0" tIns="0" bIns="0" anchor="t">
+            <a:spAutoFit/>
+          </a:bodyPr>
+          <a:lstStyle/>
+          <a:p>
+            <a:pPr algn="l"/>
+            <a:r>
+              <a:rPr sz="8800" b="0">
+                <a:solidFill>
+                  <a:srgbClr val="F2EDE3"/>
+                </a:solidFill>
+                <a:latin typeface="Anton"/>
+              </a:rPr>
+              <a:t>GRACIAS</a:t>
+            </a:r>
+          </a:p>
+        </p:txBody>
+      </p:sp>
+      <p:sp>
+        <p:nvSpPr>
+          <p:cNvPr id="4" name="TextBox 3"/>
+          <p:cNvSpPr txBox="1"/>
+          <p:nvPr/>
+        </p:nvSpPr>
+        <p:spPr>
+          <a:xfrm>
+            <a:off x="548640" y="3931920"/>
+            <a:ext cx="6400800" cy="411480"/>
+          </a:xfrm>
+          <a:prstGeom prst="rect">
+            <a:avLst/>
+          </a:prstGeom>
+          <a:noFill/>
+        </p:spPr>
+        <p:txBody>
+          <a:bodyPr wrap="square" lIns="0" rIns="0" tIns="0" bIns="0" anchor="t">
+            <a:spAutoFit/>
+          </a:bodyPr>
+          <a:lstStyle/>
+          <a:p>
+            <a:pPr algn="l"/>
+            <a:r>
+              <a:rPr sz="1800" b="0">
+                <a:solidFill>
+                  <a:srgbClr val="8A8A8F"/>
+                </a:solidFill>
+                <a:latin typeface="Inter BUGS"/>
+              </a:rPr>
+              <a:t>linkedin.com/in/brandon-uriel-garcia-sanchez-9ab77b320</a:t>
+            </a:r>
+          </a:p>
+        </p:txBody>
+      </p:sp>
+      <p:sp>
+        <p:nvSpPr>
+          <p:cNvPr id="5" name="TextBox 4"/>
+          <p:cNvSpPr txBox="1"/>
+          <p:nvPr/>
+        </p:nvSpPr>
+        <p:spPr>
+          <a:xfrm>
+            <a:off x="548640" y="4389120"/>
+            <a:ext cx="6400800" cy="411480"/>
+          </a:xfrm>
+          <a:prstGeom prst="rect">
+            <a:avLst/>
+          </a:prstGeom>
+          <a:noFill/>
+        </p:spPr>
+        <p:txBody>
+          <a:bodyPr wrap="square" lIns="0" rIns="0" tIns="0" bIns="0" anchor="t">
+            <a:spAutoFit/>
+          </a:bodyPr>
+          <a:lstStyle/>
+          <a:p>
+            <a:pPr algn="l"/>
+            <a:r>
+              <a:rPr sz="1800" b="0">
+                <a:solidFill>
+                  <a:srgbClr val="8A8A8F"/>
+                </a:solidFill>
+                <a:latin typeface="Inter BUGS"/>
+              </a:rPr>
+              <a:t>github.com/CatoXP</a:t>
+            </a:r>
+          </a:p>
+        </p:txBody>
+      </p:sp>
+      <p:sp>
+        <p:nvSpPr>
+          <p:cNvPr id="6" name="Rectangle 5"/>
+          <p:cNvSpPr/>
+          <p:nvPr/>
+        </p:nvSpPr>
+        <p:spPr>
+          <a:xfrm>
+            <a:off x="0" y="6784848"/>
+            <a:ext cx="12191695" cy="73152"/>
+          </a:xfrm>
+          <a:prstGeom prst="rect">
+            <a:avLst/>
+          </a:prstGeom>
+          <a:solidFill>
+            <a:srgbClr val="FF2E3A"/>
+          </a:solidFill>
+          <a:ln>
+            <a:noFill/>
+          </a:ln>
+          <a:effectLst/>
+        </p:spPr>
+        <p:style>
+          <a:lnRef idx="1">
+            <a:schemeClr val="accent1"/>
+          </a:lnRef>
+          <a:fillRef idx="3">
+            <a:schemeClr val="accent1"/>
+          </a:fillRef>
+          <a:effectRef idx="2">
+            <a:schemeClr val="accent1"/>
+          </a:effectRef>
+          <a:fontRef idx="minor">
+            <a:schemeClr val="lt1"/>
+          </a:fontRef>
+        </p:style>
+        <p:txBody>
+          <a:bodyPr rtlCol="0" anchor="ctr"/>
+          <a:lstStyle/>
+          <a:p>
+            <a:pPr algn="ctr"/>
+          </a:p>
+        </p:txBody>
+      </p:sp>
+    </p:spTree>
+  </p:cSld>
+  <p:clrMapOvr>
+    <a:masterClrMapping/>
+  </p:clrMapOvr>
+</p:sld>
+</file>
+
 <file path=ppt/slides/slide2.xml><?xml version="1.0" encoding="utf-8"?>
 <p:sld xmlns:a="http://schemas.openxmlformats.org/drawingml/2006/main" xmlns:p="http://schemas.openxmlformats.org/presentationml/2006/main" xmlns:r="http://schemas.openxmlformats.org/officeDocument/2006/relationships">
   <p:cSld>
@@ -3879,14 +4099,49 @@
                 </a:solidFill>
                 <a:latin typeface="Anton"/>
               </a:rPr>
-              <a:t>CÓMO SE CONSTRUYÓ EL SCORE</a:t>
+              <a:t>LOS SCORES EXTERNOS SEPARAN A QUIEN NO PAGA</a:t>
+            </a:r>
+          </a:p>
+        </p:txBody>
+      </p:sp>
+      <p:sp>
+        <p:nvSpPr>
+          <p:cNvPr id="7" name="TextBox 6"/>
+          <p:cNvSpPr txBox="1"/>
+          <p:nvPr/>
+        </p:nvSpPr>
+        <p:spPr>
+          <a:xfrm>
+            <a:off x="822960" y="1234440"/>
+            <a:ext cx="10515600" cy="365760"/>
+          </a:xfrm>
+          <a:prstGeom prst="rect">
+            <a:avLst/>
+          </a:prstGeom>
+          <a:noFill/>
+        </p:spPr>
+        <p:txBody>
+          <a:bodyPr wrap="square" lIns="0" rIns="0" tIns="0" bIns="0" anchor="t">
+            <a:spAutoFit/>
+          </a:bodyPr>
+          <a:lstStyle/>
+          <a:p>
+            <a:pPr algn="l"/>
+            <a:r>
+              <a:rPr sz="1400" b="0">
+                <a:solidFill>
+                  <a:srgbClr val="8A8A8F"/>
+                </a:solidFill>
+                <a:latin typeface="Inter BUGS"/>
+              </a:rPr>
+              <a:t>Quienes caen en impago (rojo) tienen scores sistemáticamente más bajos; pero a EXT_SOURCE_1 le falta casi el 70% de los datos, así que lo completé con un modelo.</a:t>
             </a:r>
           </a:p>
         </p:txBody>
       </p:sp>
       <p:pic>
         <p:nvPicPr>
-          <p:cNvPr id="7" name="Picture 6" descr="cv_progression.png"/>
+          <p:cNvPr id="8" name="Picture 7" descr="eda_ext_source.png"/>
           <p:cNvPicPr>
             <a:picLocks noChangeAspect="1"/>
           </p:cNvPicPr>
@@ -3900,128 +4155,14 @@
         </p:blipFill>
         <p:spPr>
           <a:xfrm>
-            <a:off x="548640" y="1783080"/>
-            <a:ext cx="7222253" cy="4389120"/>
+            <a:off x="566638" y="1783080"/>
+            <a:ext cx="11058419" cy="4389120"/>
           </a:xfrm>
           <a:prstGeom prst="rect">
             <a:avLst/>
           </a:prstGeom>
         </p:spPr>
       </p:pic>
-      <p:sp>
-        <p:nvSpPr>
-          <p:cNvPr id="8" name="Rectangle 7"/>
-          <p:cNvSpPr/>
-          <p:nvPr/>
-        </p:nvSpPr>
-        <p:spPr>
-          <a:xfrm>
-            <a:off x="8595360" y="1783080"/>
-            <a:ext cx="73152" cy="2011680"/>
-          </a:xfrm>
-          <a:prstGeom prst="rect">
-            <a:avLst/>
-          </a:prstGeom>
-          <a:solidFill>
-            <a:srgbClr val="FF2E3A"/>
-          </a:solidFill>
-          <a:ln>
-            <a:noFill/>
-          </a:ln>
-          <a:effectLst/>
-        </p:spPr>
-        <p:style>
-          <a:lnRef idx="1">
-            <a:schemeClr val="accent1"/>
-          </a:lnRef>
-          <a:fillRef idx="3">
-            <a:schemeClr val="accent1"/>
-          </a:fillRef>
-          <a:effectRef idx="2">
-            <a:schemeClr val="accent1"/>
-          </a:effectRef>
-          <a:fontRef idx="minor">
-            <a:schemeClr val="lt1"/>
-          </a:fontRef>
-        </p:style>
-        <p:txBody>
-          <a:bodyPr rtlCol="0" anchor="ctr"/>
-          <a:lstStyle/>
-          <a:p>
-            <a:pPr algn="ctr"/>
-          </a:p>
-        </p:txBody>
-      </p:sp>
-      <p:sp>
-        <p:nvSpPr>
-          <p:cNvPr id="9" name="TextBox 8"/>
-          <p:cNvSpPr txBox="1"/>
-          <p:nvPr/>
-        </p:nvSpPr>
-        <p:spPr>
-          <a:xfrm>
-            <a:off x="8869680" y="1783080"/>
-            <a:ext cx="3017520" cy="365760"/>
-          </a:xfrm>
-          <a:prstGeom prst="rect">
-            <a:avLst/>
-          </a:prstGeom>
-          <a:noFill/>
-        </p:spPr>
-        <p:txBody>
-          <a:bodyPr wrap="square" lIns="0" rIns="0" tIns="0" bIns="0" anchor="t">
-            <a:spAutoFit/>
-          </a:bodyPr>
-          <a:lstStyle/>
-          <a:p>
-            <a:pPr algn="l"/>
-            <a:r>
-              <a:rPr sz="1400" b="0">
-                <a:solidFill>
-                  <a:srgbClr val="FF2E3A"/>
-                </a:solidFill>
-                <a:latin typeface="Anton"/>
-              </a:rPr>
-              <a:t>CONCLUSIÓN</a:t>
-            </a:r>
-          </a:p>
-        </p:txBody>
-      </p:sp>
-      <p:sp>
-        <p:nvSpPr>
-          <p:cNvPr id="10" name="TextBox 9"/>
-          <p:cNvSpPr txBox="1"/>
-          <p:nvPr/>
-        </p:nvSpPr>
-        <p:spPr>
-          <a:xfrm>
-            <a:off x="8869680" y="2240280"/>
-            <a:ext cx="3017520" cy="3200400"/>
-          </a:xfrm>
-          <a:prstGeom prst="rect">
-            <a:avLst/>
-          </a:prstGeom>
-          <a:noFill/>
-        </p:spPr>
-        <p:txBody>
-          <a:bodyPr wrap="square" lIns="0" rIns="0" tIns="0" bIns="0" anchor="t">
-            <a:spAutoFit/>
-          </a:bodyPr>
-          <a:lstStyle/>
-          <a:p>
-            <a:pPr algn="l"/>
-            <a:r>
-              <a:rPr sz="1800" b="0">
-                <a:solidFill>
-                  <a:srgbClr val="F2EDE3"/>
-                </a:solidFill>
-                <a:latin typeface="Inter BUGS"/>
-              </a:rPr>
-              <a:t>Las dos mejores mejoras salieron de entender cómo se generan los datos, no de un modelo más complejo.</a:t>
-            </a:r>
-          </a:p>
-        </p:txBody>
-      </p:sp>
     </p:spTree>
   </p:cSld>
   <p:clrMapOvr>
@@ -4236,14 +4377,49 @@
                 </a:solidFill>
                 <a:latin typeface="Anton"/>
               </a:rPr>
-              <a:t>MATEMÁTICA DE ANUALIDADES</a:t>
+              <a:t>CRÉDITO ÷ CUOTA TIENE PICOS</a:t>
+            </a:r>
+          </a:p>
+        </p:txBody>
+      </p:sp>
+      <p:sp>
+        <p:nvSpPr>
+          <p:cNvPr id="7" name="TextBox 6"/>
+          <p:cNvSpPr txBox="1"/>
+          <p:nvPr/>
+        </p:nvSpPr>
+        <p:spPr>
+          <a:xfrm>
+            <a:off x="822960" y="1234440"/>
+            <a:ext cx="10515600" cy="365760"/>
+          </a:xfrm>
+          <a:prstGeom prst="rect">
+            <a:avLst/>
+          </a:prstGeom>
+          <a:noFill/>
+        </p:spPr>
+        <p:txBody>
+          <a:bodyPr wrap="square" lIns="0" rIns="0" tIns="0" bIns="0" anchor="t">
+            <a:spAutoFit/>
+          </a:bodyPr>
+          <a:lstStyle/>
+          <a:p>
+            <a:pPr algn="l"/>
+            <a:r>
+              <a:rPr sz="1400" b="0">
+                <a:solidFill>
+                  <a:srgbClr val="8A8A8F"/>
+                </a:solidFill>
+                <a:latin typeface="Inter BUGS"/>
+              </a:rPr>
+              <a:t>Cada pico es un producto de crédito con plazo y tasa fijos: la pista para recuperar la tasa de interés oculta.</a:t>
             </a:r>
           </a:p>
         </p:txBody>
       </p:sp>
       <p:pic>
         <p:nvPicPr>
-          <p:cNvPr id="7" name="Picture 6" descr="annuity_term_rate.png"/>
+          <p:cNvPr id="8" name="Picture 7" descr="eda_credit_annuity.png"/>
           <p:cNvPicPr>
             <a:picLocks noChangeAspect="1"/>
           </p:cNvPicPr>
@@ -4257,128 +4433,14 @@
         </p:blipFill>
         <p:spPr>
           <a:xfrm>
-            <a:off x="548640" y="1783080"/>
-            <a:ext cx="7680960" cy="3652508"/>
+            <a:off x="2009568" y="1783080"/>
+            <a:ext cx="8172558" cy="4389120"/>
           </a:xfrm>
           <a:prstGeom prst="rect">
             <a:avLst/>
           </a:prstGeom>
         </p:spPr>
       </p:pic>
-      <p:sp>
-        <p:nvSpPr>
-          <p:cNvPr id="8" name="Rectangle 7"/>
-          <p:cNvSpPr/>
-          <p:nvPr/>
-        </p:nvSpPr>
-        <p:spPr>
-          <a:xfrm>
-            <a:off x="8595360" y="1783080"/>
-            <a:ext cx="73152" cy="2011680"/>
-          </a:xfrm>
-          <a:prstGeom prst="rect">
-            <a:avLst/>
-          </a:prstGeom>
-          <a:solidFill>
-            <a:srgbClr val="FF2E3A"/>
-          </a:solidFill>
-          <a:ln>
-            <a:noFill/>
-          </a:ln>
-          <a:effectLst/>
-        </p:spPr>
-        <p:style>
-          <a:lnRef idx="1">
-            <a:schemeClr val="accent1"/>
-          </a:lnRef>
-          <a:fillRef idx="3">
-            <a:schemeClr val="accent1"/>
-          </a:fillRef>
-          <a:effectRef idx="2">
-            <a:schemeClr val="accent1"/>
-          </a:effectRef>
-          <a:fontRef idx="minor">
-            <a:schemeClr val="lt1"/>
-          </a:fontRef>
-        </p:style>
-        <p:txBody>
-          <a:bodyPr rtlCol="0" anchor="ctr"/>
-          <a:lstStyle/>
-          <a:p>
-            <a:pPr algn="ctr"/>
-          </a:p>
-        </p:txBody>
-      </p:sp>
-      <p:sp>
-        <p:nvSpPr>
-          <p:cNvPr id="9" name="TextBox 8"/>
-          <p:cNvSpPr txBox="1"/>
-          <p:nvPr/>
-        </p:nvSpPr>
-        <p:spPr>
-          <a:xfrm>
-            <a:off x="8869680" y="1783080"/>
-            <a:ext cx="3017520" cy="365760"/>
-          </a:xfrm>
-          <a:prstGeom prst="rect">
-            <a:avLst/>
-          </a:prstGeom>
-          <a:noFill/>
-        </p:spPr>
-        <p:txBody>
-          <a:bodyPr wrap="square" lIns="0" rIns="0" tIns="0" bIns="0" anchor="t">
-            <a:spAutoFit/>
-          </a:bodyPr>
-          <a:lstStyle/>
-          <a:p>
-            <a:pPr algn="l"/>
-            <a:r>
-              <a:rPr sz="1400" b="0">
-                <a:solidFill>
-                  <a:srgbClr val="FF2E3A"/>
-                </a:solidFill>
-                <a:latin typeface="Anton"/>
-              </a:rPr>
-              <a:t>CONCLUSIÓN</a:t>
-            </a:r>
-          </a:p>
-        </p:txBody>
-      </p:sp>
-      <p:sp>
-        <p:nvSpPr>
-          <p:cNvPr id="10" name="TextBox 9"/>
-          <p:cNvSpPr txBox="1"/>
-          <p:nvPr/>
-        </p:nvSpPr>
-        <p:spPr>
-          <a:xfrm>
-            <a:off x="8869680" y="2240280"/>
-            <a:ext cx="3017520" cy="3200400"/>
-          </a:xfrm>
-          <a:prstGeom prst="rect">
-            <a:avLst/>
-          </a:prstGeom>
-          <a:noFill/>
-        </p:spPr>
-        <p:txBody>
-          <a:bodyPr wrap="square" lIns="0" rIns="0" tIns="0" bIns="0" anchor="t">
-            <a:spAutoFit/>
-          </a:bodyPr>
-          <a:lstStyle/>
-          <a:p>
-            <a:pPr algn="l"/>
-            <a:r>
-              <a:rPr sz="1800" b="0">
-                <a:solidFill>
-                  <a:srgbClr val="F2EDE3"/>
-                </a:solidFill>
-                <a:latin typeface="Inter BUGS"/>
-              </a:rPr>
-              <a:t>Despejar la fórmula de la cuota con bisección recupera el plazo y la tasa ocultos: los plazos de 18 y 24 meses tienen ~10% de impago.</a:t>
-            </a:r>
-          </a:p>
-        </p:txBody>
-      </p:sp>
     </p:spTree>
   </p:cSld>
   <p:clrMapOvr>
@@ -4593,14 +4655,14 @@
                 </a:solidFill>
                 <a:latin typeface="Anton"/>
               </a:rPr>
-              <a:t>EL CÓDIGO DETRÁS</a:t>
+              <a:t>CÓMO SE CONSTRUYÓ EL SCORE</a:t>
             </a:r>
           </a:p>
         </p:txBody>
       </p:sp>
       <p:pic>
         <p:nvPicPr>
-          <p:cNvPr id="7" name="Picture 6" descr="code_annuity_math.png"/>
+          <p:cNvPr id="7" name="Picture 6" descr="cv_progression.png"/>
           <p:cNvPicPr>
             <a:picLocks noChangeAspect="1"/>
           </p:cNvPicPr>
@@ -4614,14 +4676,128 @@
         </p:blipFill>
         <p:spPr>
           <a:xfrm>
-            <a:off x="1676870" y="1783080"/>
-            <a:ext cx="8837955" cy="4389120"/>
+            <a:off x="548640" y="1783080"/>
+            <a:ext cx="7222253" cy="4389120"/>
           </a:xfrm>
           <a:prstGeom prst="rect">
             <a:avLst/>
           </a:prstGeom>
         </p:spPr>
       </p:pic>
+      <p:sp>
+        <p:nvSpPr>
+          <p:cNvPr id="8" name="Rectangle 7"/>
+          <p:cNvSpPr/>
+          <p:nvPr/>
+        </p:nvSpPr>
+        <p:spPr>
+          <a:xfrm>
+            <a:off x="8595360" y="1783080"/>
+            <a:ext cx="73152" cy="2011680"/>
+          </a:xfrm>
+          <a:prstGeom prst="rect">
+            <a:avLst/>
+          </a:prstGeom>
+          <a:solidFill>
+            <a:srgbClr val="FF2E3A"/>
+          </a:solidFill>
+          <a:ln>
+            <a:noFill/>
+          </a:ln>
+          <a:effectLst/>
+        </p:spPr>
+        <p:style>
+          <a:lnRef idx="1">
+            <a:schemeClr val="accent1"/>
+          </a:lnRef>
+          <a:fillRef idx="3">
+            <a:schemeClr val="accent1"/>
+          </a:fillRef>
+          <a:effectRef idx="2">
+            <a:schemeClr val="accent1"/>
+          </a:effectRef>
+          <a:fontRef idx="minor">
+            <a:schemeClr val="lt1"/>
+          </a:fontRef>
+        </p:style>
+        <p:txBody>
+          <a:bodyPr rtlCol="0" anchor="ctr"/>
+          <a:lstStyle/>
+          <a:p>
+            <a:pPr algn="ctr"/>
+          </a:p>
+        </p:txBody>
+      </p:sp>
+      <p:sp>
+        <p:nvSpPr>
+          <p:cNvPr id="9" name="TextBox 8"/>
+          <p:cNvSpPr txBox="1"/>
+          <p:nvPr/>
+        </p:nvSpPr>
+        <p:spPr>
+          <a:xfrm>
+            <a:off x="8869680" y="1783080"/>
+            <a:ext cx="3017520" cy="365760"/>
+          </a:xfrm>
+          <a:prstGeom prst="rect">
+            <a:avLst/>
+          </a:prstGeom>
+          <a:noFill/>
+        </p:spPr>
+        <p:txBody>
+          <a:bodyPr wrap="square" lIns="0" rIns="0" tIns="0" bIns="0" anchor="t">
+            <a:spAutoFit/>
+          </a:bodyPr>
+          <a:lstStyle/>
+          <a:p>
+            <a:pPr algn="l"/>
+            <a:r>
+              <a:rPr sz="1400" b="0">
+                <a:solidFill>
+                  <a:srgbClr val="FF2E3A"/>
+                </a:solidFill>
+                <a:latin typeface="Anton"/>
+              </a:rPr>
+              <a:t>CONCLUSIÓN</a:t>
+            </a:r>
+          </a:p>
+        </p:txBody>
+      </p:sp>
+      <p:sp>
+        <p:nvSpPr>
+          <p:cNvPr id="10" name="TextBox 9"/>
+          <p:cNvSpPr txBox="1"/>
+          <p:nvPr/>
+        </p:nvSpPr>
+        <p:spPr>
+          <a:xfrm>
+            <a:off x="8869680" y="2240280"/>
+            <a:ext cx="3017520" cy="3200400"/>
+          </a:xfrm>
+          <a:prstGeom prst="rect">
+            <a:avLst/>
+          </a:prstGeom>
+          <a:noFill/>
+        </p:spPr>
+        <p:txBody>
+          <a:bodyPr wrap="square" lIns="0" rIns="0" tIns="0" bIns="0" anchor="t">
+            <a:spAutoFit/>
+          </a:bodyPr>
+          <a:lstStyle/>
+          <a:p>
+            <a:pPr algn="l"/>
+            <a:r>
+              <a:rPr sz="1800" b="0">
+                <a:solidFill>
+                  <a:srgbClr val="F2EDE3"/>
+                </a:solidFill>
+                <a:latin typeface="Inter BUGS"/>
+              </a:rPr>
+              <a:t>Las dos mejores mejoras salieron de entender cómo se generan los datos, no de un modelo más complejo.</a:t>
+            </a:r>
+          </a:p>
+        </p:txBody>
+      </p:sp>
     </p:spTree>
   </p:cSld>
   <p:clrMapOvr>
@@ -4836,14 +5012,14 @@
                 </a:solidFill>
                 <a:latin typeface="Anton"/>
               </a:rPr>
-              <a:t>QUÉ USA EL MODELO</a:t>
+              <a:t>MATEMÁTICA DE ANUALIDADES</a:t>
             </a:r>
           </a:p>
         </p:txBody>
       </p:sp>
       <p:pic>
         <p:nvPicPr>
-          <p:cNvPr id="7" name="Picture 6" descr="feature_importance.png"/>
+          <p:cNvPr id="7" name="Picture 6" descr="annuity_term_rate.png"/>
           <p:cNvPicPr>
             <a:picLocks noChangeAspect="1"/>
           </p:cNvPicPr>
@@ -4858,7 +5034,7 @@
         <p:spPr>
           <a:xfrm>
             <a:off x="548640" y="1783080"/>
-            <a:ext cx="5876717" cy="4389120"/>
+            <a:ext cx="7680960" cy="3652508"/>
           </a:xfrm>
           <a:prstGeom prst="rect">
             <a:avLst/>
@@ -4974,7 +5150,7 @@
                 </a:solidFill>
                 <a:latin typeface="Inter BUGS"/>
               </a:rPr>
-              <a:t>Los scores externos imputados y las variables de anualidad están entre las más usadas.</a:t>
+              <a:t>Despejar la fórmula de la cuota con bisección recupera el plazo y la tasa ocultos: los plazos de 18 y 24 meses tienen ~10% de impago.</a:t>
             </a:r>
           </a:p>
         </p:txBody>
@@ -5193,21 +5369,45 @@
                 </a:solidFill>
                 <a:latin typeface="Anton"/>
               </a:rPr>
-              <a:t>RESULTADOS</a:t>
-            </a:r>
-          </a:p>
-        </p:txBody>
-      </p:sp>
-      <p:sp>
-        <p:nvSpPr>
-          <p:cNvPr id="7" name="Rectangle 6"/>
+              <a:t>QUÉ USA EL MODELO</a:t>
+            </a:r>
+          </a:p>
+        </p:txBody>
+      </p:sp>
+      <p:pic>
+        <p:nvPicPr>
+          <p:cNvPr id="7" name="Picture 6" descr="feature_importance.png"/>
+          <p:cNvPicPr>
+            <a:picLocks noChangeAspect="1"/>
+          </p:cNvPicPr>
+          <p:nvPr/>
+        </p:nvPicPr>
+        <p:blipFill>
+          <a:blip r:embed="rId2"/>
+          <a:stretch>
+            <a:fillRect/>
+          </a:stretch>
+        </p:blipFill>
+        <p:spPr>
+          <a:xfrm>
+            <a:off x="548640" y="1783080"/>
+            <a:ext cx="5876717" cy="4389120"/>
+          </a:xfrm>
+          <a:prstGeom prst="rect">
+            <a:avLst/>
+          </a:prstGeom>
+        </p:spPr>
+      </p:pic>
+      <p:sp>
+        <p:nvSpPr>
+          <p:cNvPr id="8" name="Rectangle 7"/>
           <p:cNvSpPr/>
           <p:nvPr/>
         </p:nvSpPr>
         <p:spPr>
           <a:xfrm>
-            <a:off x="548640" y="2194560"/>
-            <a:ext cx="73152" cy="2926080"/>
+            <a:off x="8595360" y="1783080"/>
+            <a:ext cx="73152" cy="2011680"/>
           </a:xfrm>
           <a:prstGeom prst="rect">
             <a:avLst/>
@@ -5244,14 +5444,14 @@
       </p:sp>
       <p:sp>
         <p:nvSpPr>
-          <p:cNvPr id="8" name="TextBox 7"/>
+          <p:cNvPr id="9" name="TextBox 8"/>
           <p:cNvSpPr txBox="1"/>
           <p:nvPr/>
         </p:nvSpPr>
         <p:spPr>
           <a:xfrm>
-            <a:off x="868680" y="2103120"/>
-            <a:ext cx="3230880" cy="1645920"/>
+            <a:off x="8869680" y="1783080"/>
+            <a:ext cx="3017520" cy="365760"/>
           </a:xfrm>
           <a:prstGeom prst="rect">
             <a:avLst/>
@@ -5266,27 +5466,27 @@
           <a:p>
             <a:pPr algn="l"/>
             <a:r>
-              <a:rPr sz="7200" b="0">
+              <a:rPr sz="1400" b="0">
                 <a:solidFill>
                   <a:srgbClr val="FF2E3A"/>
                 </a:solidFill>
                 <a:latin typeface="Anton"/>
               </a:rPr>
-              <a:t>0.7743</a:t>
-            </a:r>
-          </a:p>
-        </p:txBody>
-      </p:sp>
-      <p:sp>
-        <p:nvSpPr>
-          <p:cNvPr id="9" name="TextBox 8"/>
+              <a:t>CONCLUSIÓN</a:t>
+            </a:r>
+          </a:p>
+        </p:txBody>
+      </p:sp>
+      <p:sp>
+        <p:nvSpPr>
+          <p:cNvPr id="10" name="TextBox 9"/>
           <p:cNvSpPr txBox="1"/>
           <p:nvPr/>
         </p:nvSpPr>
         <p:spPr>
           <a:xfrm>
-            <a:off x="868680" y="3840480"/>
-            <a:ext cx="3230880" cy="548640"/>
+            <a:off x="8869680" y="2240280"/>
+            <a:ext cx="3017520" cy="3200400"/>
           </a:xfrm>
           <a:prstGeom prst="rect">
             <a:avLst/>
@@ -5301,346 +5501,13 @@
           <a:p>
             <a:pPr algn="l"/>
             <a:r>
-              <a:rPr sz="2200" b="0">
+              <a:rPr sz="1800" b="0">
                 <a:solidFill>
                   <a:srgbClr val="F2EDE3"/>
-                </a:solidFill>
-                <a:latin typeface="Anton"/>
-              </a:rPr>
-              <a:t>AUC PÚBLICO</a:t>
-            </a:r>
-          </a:p>
-        </p:txBody>
-      </p:sp>
-      <p:sp>
-        <p:nvSpPr>
-          <p:cNvPr id="10" name="TextBox 9"/>
-          <p:cNvSpPr txBox="1"/>
-          <p:nvPr/>
-        </p:nvSpPr>
-        <p:spPr>
-          <a:xfrm>
-            <a:off x="868680" y="4434840"/>
-            <a:ext cx="3230880" cy="731520"/>
-          </a:xfrm>
-          <a:prstGeom prst="rect">
-            <a:avLst/>
-          </a:prstGeom>
-          <a:noFill/>
-        </p:spPr>
-        <p:txBody>
-          <a:bodyPr wrap="square" lIns="0" rIns="0" tIns="0" bIns="0" anchor="t">
-            <a:spAutoFit/>
-          </a:bodyPr>
-          <a:lstStyle/>
-          <a:p>
-            <a:pPr algn="l"/>
-            <a:r>
-              <a:rPr sz="1400" b="0">
-                <a:solidFill>
-                  <a:srgbClr val="8A8A8F"/>
                 </a:solidFill>
                 <a:latin typeface="Inter BUGS"/>
               </a:rPr>
-              <a:t>leaderboard de la competencia</a:t>
-            </a:r>
-          </a:p>
-        </p:txBody>
-      </p:sp>
-      <p:sp>
-        <p:nvSpPr>
-          <p:cNvPr id="11" name="Rectangle 10"/>
-          <p:cNvSpPr/>
-          <p:nvPr/>
-        </p:nvSpPr>
-        <p:spPr>
-          <a:xfrm>
-            <a:off x="4236720" y="2194560"/>
-            <a:ext cx="73152" cy="2926080"/>
-          </a:xfrm>
-          <a:prstGeom prst="rect">
-            <a:avLst/>
-          </a:prstGeom>
-          <a:solidFill>
-            <a:srgbClr val="17171A"/>
-          </a:solidFill>
-          <a:ln>
-            <a:noFill/>
-          </a:ln>
-          <a:effectLst/>
-        </p:spPr>
-        <p:style>
-          <a:lnRef idx="1">
-            <a:schemeClr val="accent1"/>
-          </a:lnRef>
-          <a:fillRef idx="3">
-            <a:schemeClr val="accent1"/>
-          </a:fillRef>
-          <a:effectRef idx="2">
-            <a:schemeClr val="accent1"/>
-          </a:effectRef>
-          <a:fontRef idx="minor">
-            <a:schemeClr val="lt1"/>
-          </a:fontRef>
-        </p:style>
-        <p:txBody>
-          <a:bodyPr rtlCol="0" anchor="ctr"/>
-          <a:lstStyle/>
-          <a:p>
-            <a:pPr algn="ctr"/>
-          </a:p>
-        </p:txBody>
-      </p:sp>
-      <p:sp>
-        <p:nvSpPr>
-          <p:cNvPr id="12" name="TextBox 11"/>
-          <p:cNvSpPr txBox="1"/>
-          <p:nvPr/>
-        </p:nvSpPr>
-        <p:spPr>
-          <a:xfrm>
-            <a:off x="4556760" y="2103120"/>
-            <a:ext cx="3230880" cy="1645920"/>
-          </a:xfrm>
-          <a:prstGeom prst="rect">
-            <a:avLst/>
-          </a:prstGeom>
-          <a:noFill/>
-        </p:spPr>
-        <p:txBody>
-          <a:bodyPr wrap="square" lIns="0" rIns="0" tIns="0" bIns="0" anchor="t">
-            <a:spAutoFit/>
-          </a:bodyPr>
-          <a:lstStyle/>
-          <a:p>
-            <a:pPr algn="l"/>
-            <a:r>
-              <a:rPr sz="7200" b="0">
-                <a:solidFill>
-                  <a:srgbClr val="F2EDE3"/>
-                </a:solidFill>
-                <a:latin typeface="Anton"/>
-              </a:rPr>
-              <a:t>0.7700</a:t>
-            </a:r>
-          </a:p>
-        </p:txBody>
-      </p:sp>
-      <p:sp>
-        <p:nvSpPr>
-          <p:cNvPr id="13" name="TextBox 12"/>
-          <p:cNvSpPr txBox="1"/>
-          <p:nvPr/>
-        </p:nvSpPr>
-        <p:spPr>
-          <a:xfrm>
-            <a:off x="4556760" y="3840480"/>
-            <a:ext cx="3230880" cy="548640"/>
-          </a:xfrm>
-          <a:prstGeom prst="rect">
-            <a:avLst/>
-          </a:prstGeom>
-          <a:noFill/>
-        </p:spPr>
-        <p:txBody>
-          <a:bodyPr wrap="square" lIns="0" rIns="0" tIns="0" bIns="0" anchor="t">
-            <a:spAutoFit/>
-          </a:bodyPr>
-          <a:lstStyle/>
-          <a:p>
-            <a:pPr algn="l"/>
-            <a:r>
-              <a:rPr sz="2200" b="0">
-                <a:solidFill>
-                  <a:srgbClr val="F2EDE3"/>
-                </a:solidFill>
-                <a:latin typeface="Anton"/>
-              </a:rPr>
-              <a:t>AUC EN CV</a:t>
-            </a:r>
-          </a:p>
-        </p:txBody>
-      </p:sp>
-      <p:sp>
-        <p:nvSpPr>
-          <p:cNvPr id="14" name="TextBox 13"/>
-          <p:cNvSpPr txBox="1"/>
-          <p:nvPr/>
-        </p:nvSpPr>
-        <p:spPr>
-          <a:xfrm>
-            <a:off x="4556760" y="4434840"/>
-            <a:ext cx="3230880" cy="731520"/>
-          </a:xfrm>
-          <a:prstGeom prst="rect">
-            <a:avLst/>
-          </a:prstGeom>
-          <a:noFill/>
-        </p:spPr>
-        <p:txBody>
-          <a:bodyPr wrap="square" lIns="0" rIns="0" tIns="0" bIns="0" anchor="t">
-            <a:spAutoFit/>
-          </a:bodyPr>
-          <a:lstStyle/>
-          <a:p>
-            <a:pPr algn="l"/>
-            <a:r>
-              <a:rPr sz="1400" b="0">
-                <a:solidFill>
-                  <a:srgbClr val="8A8A8F"/>
-                </a:solidFill>
-                <a:latin typeface="Inter BUGS"/>
-              </a:rPr>
-              <a:t>5 folds, sin fuga de datos</a:t>
-            </a:r>
-          </a:p>
-        </p:txBody>
-      </p:sp>
-      <p:sp>
-        <p:nvSpPr>
-          <p:cNvPr id="15" name="Rectangle 14"/>
-          <p:cNvSpPr/>
-          <p:nvPr/>
-        </p:nvSpPr>
-        <p:spPr>
-          <a:xfrm>
-            <a:off x="7924800" y="2194560"/>
-            <a:ext cx="73152" cy="2926080"/>
-          </a:xfrm>
-          <a:prstGeom prst="rect">
-            <a:avLst/>
-          </a:prstGeom>
-          <a:solidFill>
-            <a:srgbClr val="17171A"/>
-          </a:solidFill>
-          <a:ln>
-            <a:noFill/>
-          </a:ln>
-          <a:effectLst/>
-        </p:spPr>
-        <p:style>
-          <a:lnRef idx="1">
-            <a:schemeClr val="accent1"/>
-          </a:lnRef>
-          <a:fillRef idx="3">
-            <a:schemeClr val="accent1"/>
-          </a:fillRef>
-          <a:effectRef idx="2">
-            <a:schemeClr val="accent1"/>
-          </a:effectRef>
-          <a:fontRef idx="minor">
-            <a:schemeClr val="lt1"/>
-          </a:fontRef>
-        </p:style>
-        <p:txBody>
-          <a:bodyPr rtlCol="0" anchor="ctr"/>
-          <a:lstStyle/>
-          <a:p>
-            <a:pPr algn="ctr"/>
-          </a:p>
-        </p:txBody>
-      </p:sp>
-      <p:sp>
-        <p:nvSpPr>
-          <p:cNvPr id="16" name="TextBox 15"/>
-          <p:cNvSpPr txBox="1"/>
-          <p:nvPr/>
-        </p:nvSpPr>
-        <p:spPr>
-          <a:xfrm>
-            <a:off x="8244840" y="2103120"/>
-            <a:ext cx="3230880" cy="1645920"/>
-          </a:xfrm>
-          <a:prstGeom prst="rect">
-            <a:avLst/>
-          </a:prstGeom>
-          <a:noFill/>
-        </p:spPr>
-        <p:txBody>
-          <a:bodyPr wrap="square" lIns="0" rIns="0" tIns="0" bIns="0" anchor="t">
-            <a:spAutoFit/>
-          </a:bodyPr>
-          <a:lstStyle/>
-          <a:p>
-            <a:pPr algn="l"/>
-            <a:r>
-              <a:rPr sz="7200" b="0">
-                <a:solidFill>
-                  <a:srgbClr val="F2EDE3"/>
-                </a:solidFill>
-                <a:latin typeface="Anton"/>
-              </a:rPr>
-              <a:t>+0.009</a:t>
-            </a:r>
-          </a:p>
-        </p:txBody>
-      </p:sp>
-      <p:sp>
-        <p:nvSpPr>
-          <p:cNvPr id="17" name="TextBox 16"/>
-          <p:cNvSpPr txBox="1"/>
-          <p:nvPr/>
-        </p:nvSpPr>
-        <p:spPr>
-          <a:xfrm>
-            <a:off x="8244840" y="3840480"/>
-            <a:ext cx="3230880" cy="548640"/>
-          </a:xfrm>
-          <a:prstGeom prst="rect">
-            <a:avLst/>
-          </a:prstGeom>
-          <a:noFill/>
-        </p:spPr>
-        <p:txBody>
-          <a:bodyPr wrap="square" lIns="0" rIns="0" tIns="0" bIns="0" anchor="t">
-            <a:spAutoFit/>
-          </a:bodyPr>
-          <a:lstStyle/>
-          <a:p>
-            <a:pPr algn="l"/>
-            <a:r>
-              <a:rPr sz="2200" b="0">
-                <a:solidFill>
-                  <a:srgbClr val="F2EDE3"/>
-                </a:solidFill>
-                <a:latin typeface="Anton"/>
-              </a:rPr>
-              <a:t>VS. BASELINE</a:t>
-            </a:r>
-          </a:p>
-        </p:txBody>
-      </p:sp>
-      <p:sp>
-        <p:nvSpPr>
-          <p:cNvPr id="18" name="TextBox 17"/>
-          <p:cNvSpPr txBox="1"/>
-          <p:nvPr/>
-        </p:nvSpPr>
-        <p:spPr>
-          <a:xfrm>
-            <a:off x="8244840" y="4434840"/>
-            <a:ext cx="3230880" cy="731520"/>
-          </a:xfrm>
-          <a:prstGeom prst="rect">
-            <a:avLst/>
-          </a:prstGeom>
-          <a:noFill/>
-        </p:spPr>
-        <p:txBody>
-          <a:bodyPr wrap="square" lIns="0" rIns="0" tIns="0" bIns="0" anchor="t">
-            <a:spAutoFit/>
-          </a:bodyPr>
-          <a:lstStyle/>
-          <a:p>
-            <a:pPr algn="l"/>
-            <a:r>
-              <a:rPr sz="1400" b="0">
-                <a:solidFill>
-                  <a:srgbClr val="8A8A8F"/>
-                </a:solidFill>
-                <a:latin typeface="Inter BUGS"/>
-              </a:rPr>
-              <a:t>8 pasos medidos</a:t>
+              <a:t>Los scores externos imputados y las variables de anualidad están entre las más usadas.</a:t>
             </a:r>
           </a:p>
         </p:txBody>
@@ -5859,21 +5726,65 @@
                 </a:solidFill>
                 <a:latin typeface="Anton"/>
               </a:rPr>
-              <a:t>LO QUE APRENDÍ</a:t>
-            </a:r>
-          </a:p>
-        </p:txBody>
-      </p:sp>
-      <p:sp>
-        <p:nvSpPr>
-          <p:cNvPr id="7" name="TextBox 6"/>
+              <a:t>RESULTADOS</a:t>
+            </a:r>
+          </a:p>
+        </p:txBody>
+      </p:sp>
+      <p:sp>
+        <p:nvSpPr>
+          <p:cNvPr id="7" name="Rectangle 6"/>
+          <p:cNvSpPr/>
+          <p:nvPr/>
+        </p:nvSpPr>
+        <p:spPr>
+          <a:xfrm>
+            <a:off x="548640" y="2194560"/>
+            <a:ext cx="73152" cy="2926080"/>
+          </a:xfrm>
+          <a:prstGeom prst="rect">
+            <a:avLst/>
+          </a:prstGeom>
+          <a:solidFill>
+            <a:srgbClr val="FF2E3A"/>
+          </a:solidFill>
+          <a:ln>
+            <a:noFill/>
+          </a:ln>
+          <a:effectLst/>
+        </p:spPr>
+        <p:style>
+          <a:lnRef idx="1">
+            <a:schemeClr val="accent1"/>
+          </a:lnRef>
+          <a:fillRef idx="3">
+            <a:schemeClr val="accent1"/>
+          </a:fillRef>
+          <a:effectRef idx="2">
+            <a:schemeClr val="accent1"/>
+          </a:effectRef>
+          <a:fontRef idx="minor">
+            <a:schemeClr val="lt1"/>
+          </a:fontRef>
+        </p:style>
+        <p:txBody>
+          <a:bodyPr rtlCol="0" anchor="ctr"/>
+          <a:lstStyle/>
+          <a:p>
+            <a:pPr algn="ctr"/>
+          </a:p>
+        </p:txBody>
+      </p:sp>
+      <p:sp>
+        <p:nvSpPr>
+          <p:cNvPr id="8" name="TextBox 7"/>
           <p:cNvSpPr txBox="1"/>
           <p:nvPr/>
         </p:nvSpPr>
         <p:spPr>
           <a:xfrm>
-            <a:off x="822960" y="2011680"/>
-            <a:ext cx="914400" cy="731520"/>
+            <a:off x="868680" y="2103120"/>
+            <a:ext cx="3230880" cy="1645920"/>
           </a:xfrm>
           <a:prstGeom prst="rect">
             <a:avLst/>
@@ -5888,27 +5799,27 @@
           <a:p>
             <a:pPr algn="l"/>
             <a:r>
-              <a:rPr sz="3000" b="0">
+              <a:rPr sz="7200" b="0">
                 <a:solidFill>
                   <a:srgbClr val="FF2E3A"/>
                 </a:solidFill>
                 <a:latin typeface="Anton"/>
               </a:rPr>
-              <a:t>01</a:t>
-            </a:r>
-          </a:p>
-        </p:txBody>
-      </p:sp>
-      <p:sp>
-        <p:nvSpPr>
-          <p:cNvPr id="8" name="TextBox 7"/>
+              <a:t>0.7743</a:t>
+            </a:r>
+          </a:p>
+        </p:txBody>
+      </p:sp>
+      <p:sp>
+        <p:nvSpPr>
+          <p:cNvPr id="9" name="TextBox 8"/>
           <p:cNvSpPr txBox="1"/>
           <p:nvPr/>
         </p:nvSpPr>
         <p:spPr>
           <a:xfrm>
-            <a:off x="1828800" y="2084832"/>
-            <a:ext cx="9509760" cy="914400"/>
+            <a:off x="868680" y="3840480"/>
+            <a:ext cx="3230880" cy="548640"/>
           </a:xfrm>
           <a:prstGeom prst="rect">
             <a:avLst/>
@@ -5927,23 +5838,23 @@
                 <a:solidFill>
                   <a:srgbClr val="F2EDE3"/>
                 </a:solidFill>
-                <a:latin typeface="Inter BUGS"/>
+                <a:latin typeface="Anton"/>
               </a:rPr>
-              <a:t>Entender cómo se generan los datos vale más que cambiar de modelo</a:t>
-            </a:r>
-          </a:p>
-        </p:txBody>
-      </p:sp>
-      <p:sp>
-        <p:nvSpPr>
-          <p:cNvPr id="9" name="TextBox 8"/>
+              <a:t>AUC PÚBLICO</a:t>
+            </a:r>
+          </a:p>
+        </p:txBody>
+      </p:sp>
+      <p:sp>
+        <p:nvSpPr>
+          <p:cNvPr id="10" name="TextBox 9"/>
           <p:cNvSpPr txBox="1"/>
           <p:nvPr/>
         </p:nvSpPr>
         <p:spPr>
           <a:xfrm>
-            <a:off x="822960" y="3063240"/>
-            <a:ext cx="914400" cy="731520"/>
+            <a:off x="868680" y="4434840"/>
+            <a:ext cx="3230880" cy="731520"/>
           </a:xfrm>
           <a:prstGeom prst="rect">
             <a:avLst/>
@@ -5958,27 +5869,71 @@
           <a:p>
             <a:pPr algn="l"/>
             <a:r>
-              <a:rPr sz="3000" b="0">
-                <a:solidFill>
-                  <a:srgbClr val="FF2E3A"/>
-                </a:solidFill>
-                <a:latin typeface="Anton"/>
+              <a:rPr sz="1400" b="0">
+                <a:solidFill>
+                  <a:srgbClr val="8A8A8F"/>
+                </a:solidFill>
+                <a:latin typeface="Inter BUGS"/>
               </a:rPr>
-              <a:t>02</a:t>
-            </a:r>
-          </a:p>
-        </p:txBody>
-      </p:sp>
-      <p:sp>
-        <p:nvSpPr>
-          <p:cNvPr id="10" name="TextBox 9"/>
+              <a:t>leaderboard de la competencia</a:t>
+            </a:r>
+          </a:p>
+        </p:txBody>
+      </p:sp>
+      <p:sp>
+        <p:nvSpPr>
+          <p:cNvPr id="11" name="Rectangle 10"/>
+          <p:cNvSpPr/>
+          <p:nvPr/>
+        </p:nvSpPr>
+        <p:spPr>
+          <a:xfrm>
+            <a:off x="4236720" y="2194560"/>
+            <a:ext cx="73152" cy="2926080"/>
+          </a:xfrm>
+          <a:prstGeom prst="rect">
+            <a:avLst/>
+          </a:prstGeom>
+          <a:solidFill>
+            <a:srgbClr val="17171A"/>
+          </a:solidFill>
+          <a:ln>
+            <a:noFill/>
+          </a:ln>
+          <a:effectLst/>
+        </p:spPr>
+        <p:style>
+          <a:lnRef idx="1">
+            <a:schemeClr val="accent1"/>
+          </a:lnRef>
+          <a:fillRef idx="3">
+            <a:schemeClr val="accent1"/>
+          </a:fillRef>
+          <a:effectRef idx="2">
+            <a:schemeClr val="accent1"/>
+          </a:effectRef>
+          <a:fontRef idx="minor">
+            <a:schemeClr val="lt1"/>
+          </a:fontRef>
+        </p:style>
+        <p:txBody>
+          <a:bodyPr rtlCol="0" anchor="ctr"/>
+          <a:lstStyle/>
+          <a:p>
+            <a:pPr algn="ctr"/>
+          </a:p>
+        </p:txBody>
+      </p:sp>
+      <p:sp>
+        <p:nvSpPr>
+          <p:cNvPr id="12" name="TextBox 11"/>
           <p:cNvSpPr txBox="1"/>
           <p:nvPr/>
         </p:nvSpPr>
         <p:spPr>
           <a:xfrm>
-            <a:off x="1828800" y="3136392"/>
-            <a:ext cx="9509760" cy="914400"/>
+            <a:off x="4556760" y="2103120"/>
+            <a:ext cx="3230880" cy="1645920"/>
           </a:xfrm>
           <a:prstGeom prst="rect">
             <a:avLst/>
@@ -5993,27 +5948,27 @@
           <a:p>
             <a:pPr algn="l"/>
             <a:r>
-              <a:rPr sz="2200" b="0">
+              <a:rPr sz="7200" b="0">
                 <a:solidFill>
                   <a:srgbClr val="F2EDE3"/>
                 </a:solidFill>
-                <a:latin typeface="Inter BUGS"/>
+                <a:latin typeface="Anton"/>
               </a:rPr>
-              <a:t>Las matemáticas son una herramienta de feature engineering</a:t>
-            </a:r>
-          </a:p>
-        </p:txBody>
-      </p:sp>
-      <p:sp>
-        <p:nvSpPr>
-          <p:cNvPr id="11" name="TextBox 10"/>
+              <a:t>0.7700</a:t>
+            </a:r>
+          </a:p>
+        </p:txBody>
+      </p:sp>
+      <p:sp>
+        <p:nvSpPr>
+          <p:cNvPr id="13" name="TextBox 12"/>
           <p:cNvSpPr txBox="1"/>
           <p:nvPr/>
         </p:nvSpPr>
         <p:spPr>
           <a:xfrm>
-            <a:off x="822960" y="4114800"/>
-            <a:ext cx="914400" cy="731520"/>
+            <a:off x="4556760" y="3840480"/>
+            <a:ext cx="3230880" cy="548640"/>
           </a:xfrm>
           <a:prstGeom prst="rect">
             <a:avLst/>
@@ -6028,27 +5983,27 @@
           <a:p>
             <a:pPr algn="l"/>
             <a:r>
-              <a:rPr sz="3000" b="0">
-                <a:solidFill>
-                  <a:srgbClr val="FF2E3A"/>
+              <a:rPr sz="2200" b="0">
+                <a:solidFill>
+                  <a:srgbClr val="F2EDE3"/>
                 </a:solidFill>
                 <a:latin typeface="Anton"/>
               </a:rPr>
-              <a:t>03</a:t>
-            </a:r>
-          </a:p>
-        </p:txBody>
-      </p:sp>
-      <p:sp>
-        <p:nvSpPr>
-          <p:cNvPr id="12" name="TextBox 11"/>
+              <a:t>AUC EN CV</a:t>
+            </a:r>
+          </a:p>
+        </p:txBody>
+      </p:sp>
+      <p:sp>
+        <p:nvSpPr>
+          <p:cNvPr id="14" name="TextBox 13"/>
           <p:cNvSpPr txBox="1"/>
           <p:nvPr/>
         </p:nvSpPr>
         <p:spPr>
           <a:xfrm>
-            <a:off x="1828800" y="4187952"/>
-            <a:ext cx="9509760" cy="914400"/>
+            <a:off x="4556760" y="4434840"/>
+            <a:ext cx="3230880" cy="731520"/>
           </a:xfrm>
           <a:prstGeom prst="rect">
             <a:avLst/>
@@ -6063,27 +6018,71 @@
           <a:p>
             <a:pPr algn="l"/>
             <a:r>
-              <a:rPr sz="2200" b="0">
-                <a:solidFill>
-                  <a:srgbClr val="F2EDE3"/>
+              <a:rPr sz="1400" b="0">
+                <a:solidFill>
+                  <a:srgbClr val="8A8A8F"/>
                 </a:solidFill>
                 <a:latin typeface="Inter BUGS"/>
               </a:rPr>
-              <a:t>Validar sin fuga es lo que permite confiar en el resultado</a:t>
-            </a:r>
-          </a:p>
-        </p:txBody>
-      </p:sp>
-      <p:sp>
-        <p:nvSpPr>
-          <p:cNvPr id="13" name="TextBox 12"/>
+              <a:t>5 folds, sin fuga de datos</a:t>
+            </a:r>
+          </a:p>
+        </p:txBody>
+      </p:sp>
+      <p:sp>
+        <p:nvSpPr>
+          <p:cNvPr id="15" name="Rectangle 14"/>
+          <p:cNvSpPr/>
+          <p:nvPr/>
+        </p:nvSpPr>
+        <p:spPr>
+          <a:xfrm>
+            <a:off x="7924800" y="2194560"/>
+            <a:ext cx="73152" cy="2926080"/>
+          </a:xfrm>
+          <a:prstGeom prst="rect">
+            <a:avLst/>
+          </a:prstGeom>
+          <a:solidFill>
+            <a:srgbClr val="17171A"/>
+          </a:solidFill>
+          <a:ln>
+            <a:noFill/>
+          </a:ln>
+          <a:effectLst/>
+        </p:spPr>
+        <p:style>
+          <a:lnRef idx="1">
+            <a:schemeClr val="accent1"/>
+          </a:lnRef>
+          <a:fillRef idx="3">
+            <a:schemeClr val="accent1"/>
+          </a:fillRef>
+          <a:effectRef idx="2">
+            <a:schemeClr val="accent1"/>
+          </a:effectRef>
+          <a:fontRef idx="minor">
+            <a:schemeClr val="lt1"/>
+          </a:fontRef>
+        </p:style>
+        <p:txBody>
+          <a:bodyPr rtlCol="0" anchor="ctr"/>
+          <a:lstStyle/>
+          <a:p>
+            <a:pPr algn="ctr"/>
+          </a:p>
+        </p:txBody>
+      </p:sp>
+      <p:sp>
+        <p:nvSpPr>
+          <p:cNvPr id="16" name="TextBox 15"/>
           <p:cNvSpPr txBox="1"/>
           <p:nvPr/>
         </p:nvSpPr>
         <p:spPr>
           <a:xfrm>
-            <a:off x="822960" y="5166360"/>
-            <a:ext cx="914400" cy="731520"/>
+            <a:off x="8244840" y="2103120"/>
+            <a:ext cx="3230880" cy="1645920"/>
           </a:xfrm>
           <a:prstGeom prst="rect">
             <a:avLst/>
@@ -6098,27 +6097,27 @@
           <a:p>
             <a:pPr algn="l"/>
             <a:r>
-              <a:rPr sz="3000" b="0">
-                <a:solidFill>
-                  <a:srgbClr val="FF2E3A"/>
+              <a:rPr sz="7200" b="0">
+                <a:solidFill>
+                  <a:srgbClr val="F2EDE3"/>
                 </a:solidFill>
                 <a:latin typeface="Anton"/>
               </a:rPr>
-              <a:t>04</a:t>
-            </a:r>
-          </a:p>
-        </p:txBody>
-      </p:sp>
-      <p:sp>
-        <p:nvSpPr>
-          <p:cNvPr id="14" name="TextBox 13"/>
+              <a:t>+0.009</a:t>
+            </a:r>
+          </a:p>
+        </p:txBody>
+      </p:sp>
+      <p:sp>
+        <p:nvSpPr>
+          <p:cNvPr id="17" name="TextBox 16"/>
           <p:cNvSpPr txBox="1"/>
           <p:nvPr/>
         </p:nvSpPr>
         <p:spPr>
           <a:xfrm>
-            <a:off x="1828800" y="5239512"/>
-            <a:ext cx="9509760" cy="914400"/>
+            <a:off x="8244840" y="3840480"/>
+            <a:ext cx="3230880" cy="548640"/>
           </a:xfrm>
           <a:prstGeom prst="rect">
             <a:avLst/>
@@ -6137,9 +6136,44 @@
                 <a:solidFill>
                   <a:srgbClr val="F2EDE3"/>
                 </a:solidFill>
+                <a:latin typeface="Anton"/>
+              </a:rPr>
+              <a:t>VS. BASELINE</a:t>
+            </a:r>
+          </a:p>
+        </p:txBody>
+      </p:sp>
+      <p:sp>
+        <p:nvSpPr>
+          <p:cNvPr id="18" name="TextBox 17"/>
+          <p:cNvSpPr txBox="1"/>
+          <p:nvPr/>
+        </p:nvSpPr>
+        <p:spPr>
+          <a:xfrm>
+            <a:off x="8244840" y="4434840"/>
+            <a:ext cx="3230880" cy="731520"/>
+          </a:xfrm>
+          <a:prstGeom prst="rect">
+            <a:avLst/>
+          </a:prstGeom>
+          <a:noFill/>
+        </p:spPr>
+        <p:txBody>
+          <a:bodyPr wrap="square" lIns="0" rIns="0" tIns="0" bIns="0" anchor="t">
+            <a:spAutoFit/>
+          </a:bodyPr>
+          <a:lstStyle/>
+          <a:p>
+            <a:pPr algn="l"/>
+            <a:r>
+              <a:rPr sz="1400" b="0">
+                <a:solidFill>
+                  <a:srgbClr val="8A8A8F"/>
+                </a:solidFill>
                 <a:latin typeface="Inter BUGS"/>
               </a:rPr>
-              <a:t>Documentar lo que no funcionó también es parte del trabajo</a:t>
+              <a:t>8 pasos medidos</a:t>
             </a:r>
           </a:p>
         </p:txBody>
@@ -6172,16 +6206,16 @@
       <p:grpSpPr/>
       <p:sp>
         <p:nvSpPr>
-          <p:cNvPr id="2" name="Parallelogram 1"/>
+          <p:cNvPr id="2" name="Rectangle 1"/>
           <p:cNvSpPr/>
           <p:nvPr/>
         </p:nvSpPr>
         <p:spPr>
           <a:xfrm>
-            <a:off x="7223760" y="0"/>
-            <a:ext cx="6035040" cy="6858000"/>
-          </a:xfrm>
-          <a:prstGeom prst="parallelogram">
+            <a:off x="0" y="6784848"/>
+            <a:ext cx="12191695" cy="73152"/>
+          </a:xfrm>
+          <a:prstGeom prst="rect">
             <a:avLst/>
           </a:prstGeom>
           <a:solidFill>
@@ -6222,8 +6256,8 @@
         </p:nvSpPr>
         <p:spPr>
           <a:xfrm>
-            <a:off x="548640" y="1828800"/>
-            <a:ext cx="6400800" cy="1828800"/>
+            <a:off x="548640" y="6400800"/>
+            <a:ext cx="8229600" cy="274320"/>
           </a:xfrm>
           <a:prstGeom prst="rect">
             <a:avLst/>
@@ -6238,13 +6272,13 @@
           <a:p>
             <a:pPr algn="l"/>
             <a:r>
-              <a:rPr sz="8800" b="0">
-                <a:solidFill>
-                  <a:srgbClr val="F2EDE3"/>
-                </a:solidFill>
-                <a:latin typeface="Anton"/>
+              <a:rPr sz="1000" b="0">
+                <a:solidFill>
+                  <a:srgbClr val="8A8A8F"/>
+                </a:solidFill>
+                <a:latin typeface="Inter BUGS"/>
               </a:rPr>
-              <a:t>GRACIAS</a:t>
+              <a:t>Home Credit Default Risk · GCI World 2026 · Brandon Uriel García Sánchez</a:t>
             </a:r>
           </a:p>
         </p:txBody>
@@ -6257,8 +6291,8 @@
         </p:nvSpPr>
         <p:spPr>
           <a:xfrm>
-            <a:off x="548640" y="3931920"/>
-            <a:ext cx="6400800" cy="411480"/>
+            <a:off x="11094415" y="6355080"/>
+            <a:ext cx="548640" cy="320040"/>
           </a:xfrm>
           <a:prstGeom prst="rect">
             <a:avLst/>
@@ -6271,64 +6305,29 @@
           </a:bodyPr>
           <a:lstStyle/>
           <a:p>
-            <a:pPr algn="l"/>
-            <a:r>
-              <a:rPr sz="1800" b="0">
-                <a:solidFill>
-                  <a:srgbClr val="8A8A8F"/>
-                </a:solidFill>
-                <a:latin typeface="Inter BUGS"/>
+            <a:pPr algn="r"/>
+            <a:r>
+              <a:rPr sz="1400" b="0">
+                <a:solidFill>
+                  <a:srgbClr val="FF2E3A"/>
+                </a:solidFill>
+                <a:latin typeface="Anton"/>
               </a:rPr>
-              <a:t>linkedin.com/in/brandon-uriel-garcia-sanchez-9ab77b320</a:t>
-            </a:r>
-          </a:p>
-        </p:txBody>
-      </p:sp>
-      <p:sp>
-        <p:nvSpPr>
-          <p:cNvPr id="5" name="TextBox 4"/>
-          <p:cNvSpPr txBox="1"/>
-          <p:nvPr/>
-        </p:nvSpPr>
-        <p:spPr>
-          <a:xfrm>
-            <a:off x="548640" y="4389120"/>
-            <a:ext cx="6400800" cy="411480"/>
-          </a:xfrm>
-          <a:prstGeom prst="rect">
-            <a:avLst/>
-          </a:prstGeom>
-          <a:noFill/>
-        </p:spPr>
-        <p:txBody>
-          <a:bodyPr wrap="square" lIns="0" rIns="0" tIns="0" bIns="0" anchor="t">
-            <a:spAutoFit/>
-          </a:bodyPr>
-          <a:lstStyle/>
-          <a:p>
-            <a:pPr algn="l"/>
-            <a:r>
-              <a:rPr sz="1800" b="0">
-                <a:solidFill>
-                  <a:srgbClr val="8A8A8F"/>
-                </a:solidFill>
-                <a:latin typeface="Inter BUGS"/>
-              </a:rPr>
-              <a:t>github.com/CatoXP</a:t>
-            </a:r>
-          </a:p>
-        </p:txBody>
-      </p:sp>
-      <p:sp>
-        <p:nvSpPr>
-          <p:cNvPr id="6" name="Rectangle 5"/>
+              <a:t>09</a:t>
+            </a:r>
+          </a:p>
+        </p:txBody>
+      </p:sp>
+      <p:sp>
+        <p:nvSpPr>
+          <p:cNvPr id="5" name="Rectangle 4"/>
           <p:cNvSpPr/>
           <p:nvPr/>
         </p:nvSpPr>
         <p:spPr>
           <a:xfrm>
-            <a:off x="0" y="6784848"/>
-            <a:ext cx="12191695" cy="73152"/>
+            <a:off x="548640" y="566928"/>
+            <a:ext cx="109728" cy="566928"/>
           </a:xfrm>
           <a:prstGeom prst="rect">
             <a:avLst/>
@@ -6360,6 +6359,321 @@
           <a:lstStyle/>
           <a:p>
             <a:pPr algn="ctr"/>
+          </a:p>
+        </p:txBody>
+      </p:sp>
+      <p:sp>
+        <p:nvSpPr>
+          <p:cNvPr id="6" name="TextBox 5"/>
+          <p:cNvSpPr txBox="1"/>
+          <p:nvPr/>
+        </p:nvSpPr>
+        <p:spPr>
+          <a:xfrm>
+            <a:off x="822960" y="457200"/>
+            <a:ext cx="10515600" cy="822960"/>
+          </a:xfrm>
+          <a:prstGeom prst="rect">
+            <a:avLst/>
+          </a:prstGeom>
+          <a:noFill/>
+        </p:spPr>
+        <p:txBody>
+          <a:bodyPr wrap="square" lIns="0" rIns="0" tIns="0" bIns="0" anchor="t">
+            <a:spAutoFit/>
+          </a:bodyPr>
+          <a:lstStyle/>
+          <a:p>
+            <a:pPr algn="l"/>
+            <a:r>
+              <a:rPr sz="3600" b="0">
+                <a:solidFill>
+                  <a:srgbClr val="F2EDE3"/>
+                </a:solidFill>
+                <a:latin typeface="Anton"/>
+              </a:rPr>
+              <a:t>LO QUE APRENDÍ</a:t>
+            </a:r>
+          </a:p>
+        </p:txBody>
+      </p:sp>
+      <p:sp>
+        <p:nvSpPr>
+          <p:cNvPr id="7" name="TextBox 6"/>
+          <p:cNvSpPr txBox="1"/>
+          <p:nvPr/>
+        </p:nvSpPr>
+        <p:spPr>
+          <a:xfrm>
+            <a:off x="822960" y="2011680"/>
+            <a:ext cx="914400" cy="731520"/>
+          </a:xfrm>
+          <a:prstGeom prst="rect">
+            <a:avLst/>
+          </a:prstGeom>
+          <a:noFill/>
+        </p:spPr>
+        <p:txBody>
+          <a:bodyPr wrap="square" lIns="0" rIns="0" tIns="0" bIns="0" anchor="t">
+            <a:spAutoFit/>
+          </a:bodyPr>
+          <a:lstStyle/>
+          <a:p>
+            <a:pPr algn="l"/>
+            <a:r>
+              <a:rPr sz="3000" b="0">
+                <a:solidFill>
+                  <a:srgbClr val="FF2E3A"/>
+                </a:solidFill>
+                <a:latin typeface="Anton"/>
+              </a:rPr>
+              <a:t>01</a:t>
+            </a:r>
+          </a:p>
+        </p:txBody>
+      </p:sp>
+      <p:sp>
+        <p:nvSpPr>
+          <p:cNvPr id="8" name="TextBox 7"/>
+          <p:cNvSpPr txBox="1"/>
+          <p:nvPr/>
+        </p:nvSpPr>
+        <p:spPr>
+          <a:xfrm>
+            <a:off x="1828800" y="2084832"/>
+            <a:ext cx="9509760" cy="914400"/>
+          </a:xfrm>
+          <a:prstGeom prst="rect">
+            <a:avLst/>
+          </a:prstGeom>
+          <a:noFill/>
+        </p:spPr>
+        <p:txBody>
+          <a:bodyPr wrap="square" lIns="0" rIns="0" tIns="0" bIns="0" anchor="t">
+            <a:spAutoFit/>
+          </a:bodyPr>
+          <a:lstStyle/>
+          <a:p>
+            <a:pPr algn="l"/>
+            <a:r>
+              <a:rPr sz="2200" b="0">
+                <a:solidFill>
+                  <a:srgbClr val="F2EDE3"/>
+                </a:solidFill>
+                <a:latin typeface="Inter BUGS"/>
+              </a:rPr>
+              <a:t>Entender cómo se generan los datos vale más que cambiar de modelo</a:t>
+            </a:r>
+          </a:p>
+        </p:txBody>
+      </p:sp>
+      <p:sp>
+        <p:nvSpPr>
+          <p:cNvPr id="9" name="TextBox 8"/>
+          <p:cNvSpPr txBox="1"/>
+          <p:nvPr/>
+        </p:nvSpPr>
+        <p:spPr>
+          <a:xfrm>
+            <a:off x="822960" y="3063240"/>
+            <a:ext cx="914400" cy="731520"/>
+          </a:xfrm>
+          <a:prstGeom prst="rect">
+            <a:avLst/>
+          </a:prstGeom>
+          <a:noFill/>
+        </p:spPr>
+        <p:txBody>
+          <a:bodyPr wrap="square" lIns="0" rIns="0" tIns="0" bIns="0" anchor="t">
+            <a:spAutoFit/>
+          </a:bodyPr>
+          <a:lstStyle/>
+          <a:p>
+            <a:pPr algn="l"/>
+            <a:r>
+              <a:rPr sz="3000" b="0">
+                <a:solidFill>
+                  <a:srgbClr val="FF2E3A"/>
+                </a:solidFill>
+                <a:latin typeface="Anton"/>
+              </a:rPr>
+              <a:t>02</a:t>
+            </a:r>
+          </a:p>
+        </p:txBody>
+      </p:sp>
+      <p:sp>
+        <p:nvSpPr>
+          <p:cNvPr id="10" name="TextBox 9"/>
+          <p:cNvSpPr txBox="1"/>
+          <p:nvPr/>
+        </p:nvSpPr>
+        <p:spPr>
+          <a:xfrm>
+            <a:off x="1828800" y="3136392"/>
+            <a:ext cx="9509760" cy="914400"/>
+          </a:xfrm>
+          <a:prstGeom prst="rect">
+            <a:avLst/>
+          </a:prstGeom>
+          <a:noFill/>
+        </p:spPr>
+        <p:txBody>
+          <a:bodyPr wrap="square" lIns="0" rIns="0" tIns="0" bIns="0" anchor="t">
+            <a:spAutoFit/>
+          </a:bodyPr>
+          <a:lstStyle/>
+          <a:p>
+            <a:pPr algn="l"/>
+            <a:r>
+              <a:rPr sz="2200" b="0">
+                <a:solidFill>
+                  <a:srgbClr val="F2EDE3"/>
+                </a:solidFill>
+                <a:latin typeface="Inter BUGS"/>
+              </a:rPr>
+              <a:t>Las matemáticas son una herramienta de feature engineering</a:t>
+            </a:r>
+          </a:p>
+        </p:txBody>
+      </p:sp>
+      <p:sp>
+        <p:nvSpPr>
+          <p:cNvPr id="11" name="TextBox 10"/>
+          <p:cNvSpPr txBox="1"/>
+          <p:nvPr/>
+        </p:nvSpPr>
+        <p:spPr>
+          <a:xfrm>
+            <a:off x="822960" y="4114800"/>
+            <a:ext cx="914400" cy="731520"/>
+          </a:xfrm>
+          <a:prstGeom prst="rect">
+            <a:avLst/>
+          </a:prstGeom>
+          <a:noFill/>
+        </p:spPr>
+        <p:txBody>
+          <a:bodyPr wrap="square" lIns="0" rIns="0" tIns="0" bIns="0" anchor="t">
+            <a:spAutoFit/>
+          </a:bodyPr>
+          <a:lstStyle/>
+          <a:p>
+            <a:pPr algn="l"/>
+            <a:r>
+              <a:rPr sz="3000" b="0">
+                <a:solidFill>
+                  <a:srgbClr val="FF2E3A"/>
+                </a:solidFill>
+                <a:latin typeface="Anton"/>
+              </a:rPr>
+              <a:t>03</a:t>
+            </a:r>
+          </a:p>
+        </p:txBody>
+      </p:sp>
+      <p:sp>
+        <p:nvSpPr>
+          <p:cNvPr id="12" name="TextBox 11"/>
+          <p:cNvSpPr txBox="1"/>
+          <p:nvPr/>
+        </p:nvSpPr>
+        <p:spPr>
+          <a:xfrm>
+            <a:off x="1828800" y="4187952"/>
+            <a:ext cx="9509760" cy="914400"/>
+          </a:xfrm>
+          <a:prstGeom prst="rect">
+            <a:avLst/>
+          </a:prstGeom>
+          <a:noFill/>
+        </p:spPr>
+        <p:txBody>
+          <a:bodyPr wrap="square" lIns="0" rIns="0" tIns="0" bIns="0" anchor="t">
+            <a:spAutoFit/>
+          </a:bodyPr>
+          <a:lstStyle/>
+          <a:p>
+            <a:pPr algn="l"/>
+            <a:r>
+              <a:rPr sz="2200" b="0">
+                <a:solidFill>
+                  <a:srgbClr val="F2EDE3"/>
+                </a:solidFill>
+                <a:latin typeface="Inter BUGS"/>
+              </a:rPr>
+              <a:t>Validar sin fuga es lo que permite confiar en el resultado</a:t>
+            </a:r>
+          </a:p>
+        </p:txBody>
+      </p:sp>
+      <p:sp>
+        <p:nvSpPr>
+          <p:cNvPr id="13" name="TextBox 12"/>
+          <p:cNvSpPr txBox="1"/>
+          <p:nvPr/>
+        </p:nvSpPr>
+        <p:spPr>
+          <a:xfrm>
+            <a:off x="822960" y="5166360"/>
+            <a:ext cx="914400" cy="731520"/>
+          </a:xfrm>
+          <a:prstGeom prst="rect">
+            <a:avLst/>
+          </a:prstGeom>
+          <a:noFill/>
+        </p:spPr>
+        <p:txBody>
+          <a:bodyPr wrap="square" lIns="0" rIns="0" tIns="0" bIns="0" anchor="t">
+            <a:spAutoFit/>
+          </a:bodyPr>
+          <a:lstStyle/>
+          <a:p>
+            <a:pPr algn="l"/>
+            <a:r>
+              <a:rPr sz="3000" b="0">
+                <a:solidFill>
+                  <a:srgbClr val="FF2E3A"/>
+                </a:solidFill>
+                <a:latin typeface="Anton"/>
+              </a:rPr>
+              <a:t>04</a:t>
+            </a:r>
+          </a:p>
+        </p:txBody>
+      </p:sp>
+      <p:sp>
+        <p:nvSpPr>
+          <p:cNvPr id="14" name="TextBox 13"/>
+          <p:cNvSpPr txBox="1"/>
+          <p:nvPr/>
+        </p:nvSpPr>
+        <p:spPr>
+          <a:xfrm>
+            <a:off x="1828800" y="5239512"/>
+            <a:ext cx="9509760" cy="914400"/>
+          </a:xfrm>
+          <a:prstGeom prst="rect">
+            <a:avLst/>
+          </a:prstGeom>
+          <a:noFill/>
+        </p:spPr>
+        <p:txBody>
+          <a:bodyPr wrap="square" lIns="0" rIns="0" tIns="0" bIns="0" anchor="t">
+            <a:spAutoFit/>
+          </a:bodyPr>
+          <a:lstStyle/>
+          <a:p>
+            <a:pPr algn="l"/>
+            <a:r>
+              <a:rPr sz="2200" b="0">
+                <a:solidFill>
+                  <a:srgbClr val="F2EDE3"/>
+                </a:solidFill>
+                <a:latin typeface="Inter BUGS"/>
+              </a:rPr>
+              <a:t>Documentar lo que no funcionó también es parte del trabajo</a:t>
+            </a:r>
           </a:p>
         </p:txBody>
       </p:sp>

</xml_diff>